<commit_message>
feat(tests): update presentation on the role of AI in testing engineering
</commit_message>
<xml_diff>
--- a/slide/Yapay_Zekanin_Test_Muhendisligindeki_Rolu_Sunum.pptx
+++ b/slide/Yapay_Zekanin_Test_Muhendisligindeki_Rolu_Sunum.pptx
@@ -6891,7 +6891,7 @@
                 <a:ea typeface="Calibri" pitchFamily="34" charset="-122"/>
                 <a:cs typeface="Calibri" pitchFamily="34" charset="-120"/>
               </a:rPr>
-              <a:t>7 / 7</a:t>
+              <a:t>5 / 5</a:t>
             </a:r>
             <a:endParaRPr lang="en-US" sz="1000" dirty="0"/>
           </a:p>
@@ -7010,8 +7010,8 @@
         </p:nvSpPr>
         <p:spPr>
           <a:xfrm>
-            <a:off x="2811781" y="2245154"/>
-            <a:ext cx="4578530" cy="338554"/>
+            <a:off x="0" y="2297405"/>
+            <a:ext cx="9144000" cy="338554"/>
           </a:xfrm>
           <a:prstGeom prst="rect">
             <a:avLst/>
@@ -7024,6 +7024,7 @@
           </a:bodyPr>
           <a:lstStyle/>
           <a:p>
+            <a:pPr algn="ctr"/>
             <a:r>
               <a:rPr lang="en-US" sz="1600" b="1" dirty="0">
                 <a:solidFill>
@@ -7033,6 +7034,49 @@
               </a:rPr>
               <a:t>Dinlediğiniz için teşekkür ederim</a:t>
             </a:r>
+          </a:p>
+        </p:txBody>
+      </p:sp>
+      <p:sp>
+        <p:nvSpPr>
+          <p:cNvPr id="6" name="TextBox 5">
+            <a:extLst>
+              <a:ext uri="{FF2B5EF4-FFF2-40B4-BE49-F238E27FC236}">
+                <a16:creationId xmlns:a16="http://schemas.microsoft.com/office/drawing/2014/main" id="{18E182B6-8300-893F-530A-AF0E1BEF678C}"/>
+              </a:ext>
+            </a:extLst>
+          </p:cNvPr>
+          <p:cNvSpPr txBox="1"/>
+          <p:nvPr/>
+        </p:nvSpPr>
+        <p:spPr>
+          <a:xfrm>
+            <a:off x="0" y="3390033"/>
+            <a:ext cx="9144000" cy="369332"/>
+          </a:xfrm>
+          <a:prstGeom prst="rect">
+            <a:avLst/>
+          </a:prstGeom>
+          <a:noFill/>
+        </p:spPr>
+        <p:txBody>
+          <a:bodyPr wrap="square">
+            <a:spAutoFit/>
+          </a:bodyPr>
+          <a:lstStyle/>
+          <a:p>
+            <a:pPr algn="ctr"/>
+            <a:r>
+              <a:rPr lang="en-US" dirty="0"/>
+              <a:t>GitHub Repository: </a:t>
+            </a:r>
+            <a:r>
+              <a:rPr lang="en-US" dirty="0">
+                <a:hlinkClick r:id="rId3"/>
+              </a:rPr>
+              <a:t>github.com/berkanserbes/smart-appointment-system</a:t>
+            </a:r>
+            <a:endParaRPr lang="en-US" dirty="0"/>
           </a:p>
         </p:txBody>
       </p:sp>

</xml_diff>